<commit_message>
Add speaker notes to deck; export slides PDF + rehearsal-script PDF
- build_defense_deck.py: 16 presenter notes (rehearsal script in slide notes)
- Flood_Risk_Defense_Slides.pdf (slides), Flood_Risk_Defense_Notes.pdf/.docx (script)

Co-Authored-By: Claude Opus 4.8 (1M context) <noreply@anthropic.com>
</commit_message>
<xml_diff>
--- a/Flood_Risk_Defense_Slides.pptx
+++ b/Flood_Risk_Defense_Slides.pptx
@@ -120,6 +120,1476 @@
     </a:lvl9pPr>
   </p:defaultTextStyle>
 </p:presentation>
+</file>
+
+<file path=ppt/notesMasters/notesMaster1.xml><?xml version="1.0" encoding="utf-8"?>
+<p:notesMaster xmlns:a="http://schemas.openxmlformats.org/drawingml/2006/main" xmlns:p="http://schemas.openxmlformats.org/presentationml/2006/main" xmlns:r="http://schemas.openxmlformats.org/officeDocument/2006/relationships">
+  <p:cSld>
+    <p:bg>
+      <p:bgRef idx="1001">
+        <a:schemeClr val="bg1"/>
+      </p:bgRef>
+    </p:bg>
+    <p:spTree>
+      <p:nvGrpSpPr>
+        <p:cNvPr id="1" name=""/>
+        <p:cNvGrpSpPr/>
+        <p:nvPr/>
+      </p:nvGrpSpPr>
+      <p:grpSpPr>
+        <a:xfrm>
+          <a:off x="0" y="0"/>
+          <a:ext cx="0" cy="0"/>
+          <a:chOff x="0" y="0"/>
+          <a:chExt cx="0" cy="0"/>
+        </a:xfrm>
+      </p:grpSpPr>
+      <p:sp>
+        <p:nvSpPr>
+          <p:cNvPr id="2" name="Header Placeholder 1"/>
+          <p:cNvSpPr>
+            <a:spLocks noGrp="1"/>
+          </p:cNvSpPr>
+          <p:nvPr>
+            <p:ph type="hdr" sz="quarter"/>
+          </p:nvPr>
+        </p:nvSpPr>
+        <p:spPr>
+          <a:xfrm>
+            <a:off x="0" y="0"/>
+            <a:ext cx="2971800" cy="457200"/>
+          </a:xfrm>
+          <a:prstGeom prst="rect">
+            <a:avLst/>
+          </a:prstGeom>
+        </p:spPr>
+        <p:txBody>
+          <a:bodyPr vert="horz" lIns="91440" tIns="45720" rIns="91440" bIns="45720" rtlCol="0"/>
+          <a:lstStyle>
+            <a:lvl1pPr algn="l">
+              <a:defRPr sz="1200"/>
+            </a:lvl1pPr>
+          </a:lstStyle>
+          <a:p>
+            <a:endParaRPr lang="en-US"/>
+          </a:p>
+        </p:txBody>
+      </p:sp>
+      <p:sp>
+        <p:nvSpPr>
+          <p:cNvPr id="3" name="Date Placeholder 2"/>
+          <p:cNvSpPr>
+            <a:spLocks noGrp="1"/>
+          </p:cNvSpPr>
+          <p:nvPr>
+            <p:ph type="dt" idx="1"/>
+          </p:nvPr>
+        </p:nvSpPr>
+        <p:spPr>
+          <a:xfrm>
+            <a:off x="3884613" y="0"/>
+            <a:ext cx="2971800" cy="457200"/>
+          </a:xfrm>
+          <a:prstGeom prst="rect">
+            <a:avLst/>
+          </a:prstGeom>
+        </p:spPr>
+        <p:txBody>
+          <a:bodyPr vert="horz" lIns="91440" tIns="45720" rIns="91440" bIns="45720" rtlCol="0"/>
+          <a:lstStyle>
+            <a:lvl1pPr algn="r">
+              <a:defRPr sz="1200"/>
+            </a:lvl1pPr>
+          </a:lstStyle>
+          <a:p>
+            <a:fld id="{0F89C1C7-3DCD-1040-A9CF-14679D8B5DDD}" type="datetimeFigureOut">
+              <a:rPr lang="en-US" smtClean="0"/>
+              <a:t>10/17/16</a:t>
+            </a:fld>
+            <a:endParaRPr lang="en-US"/>
+          </a:p>
+        </p:txBody>
+      </p:sp>
+      <p:sp>
+        <p:nvSpPr>
+          <p:cNvPr id="4" name="Slide Image Placeholder 3"/>
+          <p:cNvSpPr>
+            <a:spLocks noGrp="1" noRot="1" noChangeAspect="1"/>
+          </p:cNvSpPr>
+          <p:nvPr>
+            <p:ph type="sldImg" idx="2"/>
+          </p:nvPr>
+        </p:nvSpPr>
+        <p:spPr>
+          <a:xfrm>
+            <a:off x="1143000" y="685800"/>
+            <a:ext cx="4572000" cy="3429000"/>
+          </a:xfrm>
+          <a:prstGeom prst="rect">
+            <a:avLst/>
+          </a:prstGeom>
+          <a:noFill/>
+          <a:ln w="12700">
+            <a:solidFill>
+              <a:prstClr val="black"/>
+            </a:solidFill>
+          </a:ln>
+        </p:spPr>
+        <p:txBody>
+          <a:bodyPr vert="horz" lIns="91440" tIns="45720" rIns="91440" bIns="45720" rtlCol="0" anchor="ctr"/>
+          <a:lstStyle/>
+          <a:p>
+            <a:endParaRPr lang="en-US"/>
+          </a:p>
+        </p:txBody>
+      </p:sp>
+      <p:sp>
+        <p:nvSpPr>
+          <p:cNvPr id="5" name="Notes Placeholder 4"/>
+          <p:cNvSpPr>
+            <a:spLocks noGrp="1"/>
+          </p:cNvSpPr>
+          <p:nvPr>
+            <p:ph type="body" sz="quarter" idx="3"/>
+          </p:nvPr>
+        </p:nvSpPr>
+        <p:spPr>
+          <a:xfrm>
+            <a:off x="685800" y="4343400"/>
+            <a:ext cx="5486400" cy="4114800"/>
+          </a:xfrm>
+          <a:prstGeom prst="rect">
+            <a:avLst/>
+          </a:prstGeom>
+        </p:spPr>
+        <p:txBody>
+          <a:bodyPr vert="horz" lIns="91440" tIns="45720" rIns="91440" bIns="45720" rtlCol="0"/>
+          <a:lstStyle/>
+          <a:p>
+            <a:pPr lvl="0"/>
+            <a:r>
+              <a:rPr lang="en-US" smtClean="0"/>
+              <a:t>Click to edit Master text styles</a:t>
+            </a:r>
+          </a:p>
+          <a:p>
+            <a:pPr lvl="1"/>
+            <a:r>
+              <a:rPr lang="en-US" smtClean="0"/>
+              <a:t>Second level</a:t>
+            </a:r>
+          </a:p>
+          <a:p>
+            <a:pPr lvl="2"/>
+            <a:r>
+              <a:rPr lang="en-US" smtClean="0"/>
+              <a:t>Third level</a:t>
+            </a:r>
+          </a:p>
+          <a:p>
+            <a:pPr lvl="3"/>
+            <a:r>
+              <a:rPr lang="en-US" smtClean="0"/>
+              <a:t>Fourth level</a:t>
+            </a:r>
+          </a:p>
+          <a:p>
+            <a:pPr lvl="4"/>
+            <a:r>
+              <a:rPr lang="en-US" smtClean="0"/>
+              <a:t>Fifth level</a:t>
+            </a:r>
+            <a:endParaRPr lang="en-US"/>
+          </a:p>
+        </p:txBody>
+      </p:sp>
+      <p:sp>
+        <p:nvSpPr>
+          <p:cNvPr id="6" name="Footer Placeholder 5"/>
+          <p:cNvSpPr>
+            <a:spLocks noGrp="1"/>
+          </p:cNvSpPr>
+          <p:nvPr>
+            <p:ph type="ftr" sz="quarter" idx="4"/>
+          </p:nvPr>
+        </p:nvSpPr>
+        <p:spPr>
+          <a:xfrm>
+            <a:off x="0" y="8685213"/>
+            <a:ext cx="2971800" cy="457200"/>
+          </a:xfrm>
+          <a:prstGeom prst="rect">
+            <a:avLst/>
+          </a:prstGeom>
+        </p:spPr>
+        <p:txBody>
+          <a:bodyPr vert="horz" lIns="91440" tIns="45720" rIns="91440" bIns="45720" rtlCol="0" anchor="b"/>
+          <a:lstStyle>
+            <a:lvl1pPr algn="l">
+              <a:defRPr sz="1200"/>
+            </a:lvl1pPr>
+          </a:lstStyle>
+          <a:p>
+            <a:endParaRPr lang="en-US"/>
+          </a:p>
+        </p:txBody>
+      </p:sp>
+      <p:sp>
+        <p:nvSpPr>
+          <p:cNvPr id="7" name="Slide Number Placeholder 6"/>
+          <p:cNvSpPr>
+            <a:spLocks noGrp="1"/>
+          </p:cNvSpPr>
+          <p:nvPr>
+            <p:ph type="sldNum" sz="quarter" idx="5"/>
+          </p:nvPr>
+        </p:nvSpPr>
+        <p:spPr>
+          <a:xfrm>
+            <a:off x="3884613" y="8685213"/>
+            <a:ext cx="2971800" cy="457200"/>
+          </a:xfrm>
+          <a:prstGeom prst="rect">
+            <a:avLst/>
+          </a:prstGeom>
+        </p:spPr>
+        <p:txBody>
+          <a:bodyPr vert="horz" lIns="91440" tIns="45720" rIns="91440" bIns="45720" rtlCol="0" anchor="b"/>
+          <a:lstStyle>
+            <a:lvl1pPr algn="r">
+              <a:defRPr sz="1200"/>
+            </a:lvl1pPr>
+          </a:lstStyle>
+          <a:p>
+            <a:fld id="{BB5E49A5-4136-284D-997B-48E1D791AD67}" type="slidenum">
+              <a:rPr lang="en-US" smtClean="0"/>
+              <a:t>‹#›</a:t>
+            </a:fld>
+            <a:endParaRPr lang="en-US"/>
+          </a:p>
+        </p:txBody>
+      </p:sp>
+    </p:spTree>
+    <p:extLst>
+      <p:ext uri="{BB962C8B-B14F-4D97-AF65-F5344CB8AC3E}">
+        <p14:creationId xmlns:p14="http://schemas.microsoft.com/office/powerpoint/2010/main" val="2623252185"/>
+      </p:ext>
+    </p:extLst>
+  </p:cSld>
+  <p:clrMap bg1="lt1" tx1="dk1" bg2="lt2" tx2="dk2" accent1="accent1" accent2="accent2" accent3="accent3" accent4="accent4" accent5="accent5" accent6="accent6" hlink="hlink" folHlink="folHlink"/>
+  <p:notesStyle>
+    <a:lvl1pPr marL="0" algn="l" defTabSz="457200" rtl="0" eaLnBrk="1" latinLnBrk="0" hangingPunct="1">
+      <a:defRPr sz="1200" kern="1200">
+        <a:solidFill>
+          <a:schemeClr val="tx1"/>
+        </a:solidFill>
+        <a:latin typeface="+mn-lt"/>
+        <a:ea typeface="+mn-ea"/>
+        <a:cs typeface="+mn-cs"/>
+      </a:defRPr>
+    </a:lvl1pPr>
+    <a:lvl2pPr marL="457200" algn="l" defTabSz="457200" rtl="0" eaLnBrk="1" latinLnBrk="0" hangingPunct="1">
+      <a:defRPr sz="1200" kern="1200">
+        <a:solidFill>
+          <a:schemeClr val="tx1"/>
+        </a:solidFill>
+        <a:latin typeface="+mn-lt"/>
+        <a:ea typeface="+mn-ea"/>
+        <a:cs typeface="+mn-cs"/>
+      </a:defRPr>
+    </a:lvl2pPr>
+    <a:lvl3pPr marL="914400" algn="l" defTabSz="457200" rtl="0" eaLnBrk="1" latinLnBrk="0" hangingPunct="1">
+      <a:defRPr sz="1200" kern="1200">
+        <a:solidFill>
+          <a:schemeClr val="tx1"/>
+        </a:solidFill>
+        <a:latin typeface="+mn-lt"/>
+        <a:ea typeface="+mn-ea"/>
+        <a:cs typeface="+mn-cs"/>
+      </a:defRPr>
+    </a:lvl3pPr>
+    <a:lvl4pPr marL="1371600" algn="l" defTabSz="457200" rtl="0" eaLnBrk="1" latinLnBrk="0" hangingPunct="1">
+      <a:defRPr sz="1200" kern="1200">
+        <a:solidFill>
+          <a:schemeClr val="tx1"/>
+        </a:solidFill>
+        <a:latin typeface="+mn-lt"/>
+        <a:ea typeface="+mn-ea"/>
+        <a:cs typeface="+mn-cs"/>
+      </a:defRPr>
+    </a:lvl4pPr>
+    <a:lvl5pPr marL="1828800" algn="l" defTabSz="457200" rtl="0" eaLnBrk="1" latinLnBrk="0" hangingPunct="1">
+      <a:defRPr sz="1200" kern="1200">
+        <a:solidFill>
+          <a:schemeClr val="tx1"/>
+        </a:solidFill>
+        <a:latin typeface="+mn-lt"/>
+        <a:ea typeface="+mn-ea"/>
+        <a:cs typeface="+mn-cs"/>
+      </a:defRPr>
+    </a:lvl5pPr>
+    <a:lvl6pPr marL="2286000" algn="l" defTabSz="457200" rtl="0" eaLnBrk="1" latinLnBrk="0" hangingPunct="1">
+      <a:defRPr sz="1200" kern="1200">
+        <a:solidFill>
+          <a:schemeClr val="tx1"/>
+        </a:solidFill>
+        <a:latin typeface="+mn-lt"/>
+        <a:ea typeface="+mn-ea"/>
+        <a:cs typeface="+mn-cs"/>
+      </a:defRPr>
+    </a:lvl6pPr>
+    <a:lvl7pPr marL="2743200" algn="l" defTabSz="457200" rtl="0" eaLnBrk="1" latinLnBrk="0" hangingPunct="1">
+      <a:defRPr sz="1200" kern="1200">
+        <a:solidFill>
+          <a:schemeClr val="tx1"/>
+        </a:solidFill>
+        <a:latin typeface="+mn-lt"/>
+        <a:ea typeface="+mn-ea"/>
+        <a:cs typeface="+mn-cs"/>
+      </a:defRPr>
+    </a:lvl7pPr>
+    <a:lvl8pPr marL="3200400" algn="l" defTabSz="457200" rtl="0" eaLnBrk="1" latinLnBrk="0" hangingPunct="1">
+      <a:defRPr sz="1200" kern="1200">
+        <a:solidFill>
+          <a:schemeClr val="tx1"/>
+        </a:solidFill>
+        <a:latin typeface="+mn-lt"/>
+        <a:ea typeface="+mn-ea"/>
+        <a:cs typeface="+mn-cs"/>
+      </a:defRPr>
+    </a:lvl8pPr>
+    <a:lvl9pPr marL="3657600" algn="l" defTabSz="457200" rtl="0" eaLnBrk="1" latinLnBrk="0" hangingPunct="1">
+      <a:defRPr sz="1200" kern="1200">
+        <a:solidFill>
+          <a:schemeClr val="tx1"/>
+        </a:solidFill>
+        <a:latin typeface="+mn-lt"/>
+        <a:ea typeface="+mn-ea"/>
+        <a:cs typeface="+mn-cs"/>
+      </a:defRPr>
+    </a:lvl9pPr>
+  </p:notesStyle>
+</p:notesMaster>
+</file>
+
+<file path=ppt/notesSlides/notesSlide1.xml><?xml version="1.0" encoding="utf-8"?>
+<p:notes xmlns:a="http://schemas.openxmlformats.org/drawingml/2006/main" xmlns:p="http://schemas.openxmlformats.org/presentationml/2006/main" xmlns:r="http://schemas.openxmlformats.org/officeDocument/2006/relationships">
+  <p:cSld>
+    <p:spTree>
+      <p:nvGrpSpPr>
+        <p:cNvPr id="1" name=""/>
+        <p:cNvGrpSpPr/>
+        <p:nvPr/>
+      </p:nvGrpSpPr>
+      <p:grpSpPr>
+        <a:xfrm>
+          <a:off x="0" y="0"/>
+          <a:ext cx="0" cy="0"/>
+          <a:chOff x="0" y="0"/>
+          <a:chExt cx="0" cy="0"/>
+        </a:xfrm>
+      </p:grpSpPr>
+      <p:sp>
+        <p:nvSpPr>
+          <p:cNvPr id="2" name="Slide Image Placeholder 1"/>
+          <p:cNvSpPr>
+            <a:spLocks noGrp="1"/>
+          </p:cNvSpPr>
+          <p:nvPr>
+            <p:ph type="sldImg" idx="2"/>
+          </p:nvPr>
+        </p:nvSpPr>
+        <p:spPr/>
+      </p:sp>
+      <p:sp>
+        <p:nvSpPr>
+          <p:cNvPr id="3" name="Notes Placeholder 2"/>
+          <p:cNvSpPr>
+            <a:spLocks noGrp="1"/>
+          </p:cNvSpPr>
+          <p:nvPr>
+            <p:ph type="body" idx="3" sz="quarter"/>
+          </p:nvPr>
+        </p:nvSpPr>
+        <p:spPr/>
+        <p:txBody>
+          <a:bodyPr/>
+          <a:lstStyle/>
+          <a:p>
+            <a:r>
+              <a:t>Good morning. My name is Kellen Murerwa and my capstone is a geospatial machine-learning and Hidden Markov Model framework that estimates daily flood-pressure for the Nyabugogo-Nyabarongo corridor in Kigali. Over the next ten minutes I will take you through the problem, the real data, the models, and an honest evaluation. (~45s)</a:t>
+            </a:r>
+          </a:p>
+        </p:txBody>
+      </p:sp>
+      <p:sp>
+        <p:nvSpPr>
+          <p:cNvPr id="4" name="Slide Number Placeholder 3"/>
+          <p:cNvSpPr>
+            <a:spLocks noGrp="1"/>
+          </p:cNvSpPr>
+          <p:nvPr>
+            <p:ph type="sldNum" idx="5" sz="quarter"/>
+          </p:nvPr>
+        </p:nvSpPr>
+        <p:spPr/>
+      </p:sp>
+    </p:spTree>
+  </p:cSld>
+  <p:clrMapOvr>
+    <a:masterClrMapping/>
+  </p:clrMapOvr>
+</p:notes>
+</file>
+
+<file path=ppt/notesSlides/notesSlide10.xml><?xml version="1.0" encoding="utf-8"?>
+<p:notes xmlns:a="http://schemas.openxmlformats.org/drawingml/2006/main" xmlns:p="http://schemas.openxmlformats.org/presentationml/2006/main" xmlns:r="http://schemas.openxmlformats.org/officeDocument/2006/relationships">
+  <p:cSld>
+    <p:spTree>
+      <p:nvGrpSpPr>
+        <p:cNvPr id="1" name=""/>
+        <p:cNvGrpSpPr/>
+        <p:nvPr/>
+      </p:nvGrpSpPr>
+      <p:grpSpPr>
+        <a:xfrm>
+          <a:off x="0" y="0"/>
+          <a:ext cx="0" cy="0"/>
+          <a:chOff x="0" y="0"/>
+          <a:chExt cx="0" cy="0"/>
+        </a:xfrm>
+      </p:grpSpPr>
+      <p:sp>
+        <p:nvSpPr>
+          <p:cNvPr id="2" name="Slide Image Placeholder 1"/>
+          <p:cNvSpPr>
+            <a:spLocks noGrp="1"/>
+          </p:cNvSpPr>
+          <p:nvPr>
+            <p:ph type="sldImg" idx="2"/>
+          </p:nvPr>
+        </p:nvSpPr>
+        <p:spPr/>
+      </p:sp>
+      <p:sp>
+        <p:nvSpPr>
+          <p:cNvPr id="3" name="Notes Placeholder 2"/>
+          <p:cNvSpPr>
+            <a:spLocks noGrp="1"/>
+          </p:cNvSpPr>
+          <p:nvPr>
+            <p:ph type="body" idx="3" sz="quarter"/>
+          </p:nvPr>
+        </p:nvSpPr>
+        <p:spPr/>
+        <p:txBody>
+          <a:bodyPr/>
+          <a:lstStyle/>
+          <a:p>
+            <a:r>
+              <a:t>The HMM captures persistence. The self-transition probabilities are about 0.83, 0.80 and 0.91, meaning once a cell enters high pressure after sustained rain it tends to stay there, and it moves through neighbouring states rather than jumping. Next-step accuracy is 0.45 against a random baseline of 0.33.</a:t>
+            </a:r>
+          </a:p>
+        </p:txBody>
+      </p:sp>
+      <p:sp>
+        <p:nvSpPr>
+          <p:cNvPr id="4" name="Slide Number Placeholder 3"/>
+          <p:cNvSpPr>
+            <a:spLocks noGrp="1"/>
+          </p:cNvSpPr>
+          <p:nvPr>
+            <p:ph type="sldNum" idx="5" sz="quarter"/>
+          </p:nvPr>
+        </p:nvSpPr>
+        <p:spPr/>
+      </p:sp>
+    </p:spTree>
+  </p:cSld>
+  <p:clrMapOvr>
+    <a:masterClrMapping/>
+  </p:clrMapOvr>
+</p:notes>
+</file>
+
+<file path=ppt/notesSlides/notesSlide11.xml><?xml version="1.0" encoding="utf-8"?>
+<p:notes xmlns:a="http://schemas.openxmlformats.org/drawingml/2006/main" xmlns:p="http://schemas.openxmlformats.org/presentationml/2006/main" xmlns:r="http://schemas.openxmlformats.org/officeDocument/2006/relationships">
+  <p:cSld>
+    <p:spTree>
+      <p:nvGrpSpPr>
+        <p:cNvPr id="1" name=""/>
+        <p:cNvGrpSpPr/>
+        <p:nvPr/>
+      </p:nvGrpSpPr>
+      <p:grpSpPr>
+        <a:xfrm>
+          <a:off x="0" y="0"/>
+          <a:ext cx="0" cy="0"/>
+          <a:chOff x="0" y="0"/>
+          <a:chExt cx="0" cy="0"/>
+        </a:xfrm>
+      </p:grpSpPr>
+      <p:sp>
+        <p:nvSpPr>
+          <p:cNvPr id="2" name="Slide Image Placeholder 1"/>
+          <p:cNvSpPr>
+            <a:spLocks noGrp="1"/>
+          </p:cNvSpPr>
+          <p:nvPr>
+            <p:ph type="sldImg" idx="2"/>
+          </p:nvPr>
+        </p:nvSpPr>
+        <p:spPr/>
+      </p:sp>
+      <p:sp>
+        <p:nvSpPr>
+          <p:cNvPr id="3" name="Notes Placeholder 2"/>
+          <p:cNvSpPr>
+            <a:spLocks noGrp="1"/>
+          </p:cNvSpPr>
+          <p:nvPr>
+            <p:ph type="body" idx="3" sz="quarter"/>
+          </p:nvPr>
+        </p:nvSpPr>
+        <p:spPr/>
+        <p:txBody>
+          <a:bodyPr/>
+          <a:lstStyle/>
+          <a:p>
+            <a:r>
+              <a:t>Here is my most honest slide. My original target was 70% of predicted-high cells inside the official polygons. But that layer covers only 19% of my corridor, so 70% is mathematically impossible unless I make the label circular. I therefore reframed it to enrichment and an odds ratio. Predicted high-pressure is 1.59 times more concentrated in official zones than chance, and official cells are flagged high 1.84 times more often than others — and the model never saw those polygons in training. It rediscovers the official zone and extends it, which is the core contribution.</a:t>
+            </a:r>
+          </a:p>
+        </p:txBody>
+      </p:sp>
+      <p:sp>
+        <p:nvSpPr>
+          <p:cNvPr id="4" name="Slide Number Placeholder 3"/>
+          <p:cNvSpPr>
+            <a:spLocks noGrp="1"/>
+          </p:cNvSpPr>
+          <p:nvPr>
+            <p:ph type="sldNum" idx="5" sz="quarter"/>
+          </p:nvPr>
+        </p:nvSpPr>
+        <p:spPr/>
+      </p:sp>
+    </p:spTree>
+  </p:cSld>
+  <p:clrMapOvr>
+    <a:masterClrMapping/>
+  </p:clrMapOvr>
+</p:notes>
+</file>
+
+<file path=ppt/notesSlides/notesSlide12.xml><?xml version="1.0" encoding="utf-8"?>
+<p:notes xmlns:a="http://schemas.openxmlformats.org/drawingml/2006/main" xmlns:p="http://schemas.openxmlformats.org/presentationml/2006/main" xmlns:r="http://schemas.openxmlformats.org/officeDocument/2006/relationships">
+  <p:cSld>
+    <p:spTree>
+      <p:nvGrpSpPr>
+        <p:cNvPr id="1" name=""/>
+        <p:cNvGrpSpPr/>
+        <p:nvPr/>
+      </p:nvGrpSpPr>
+      <p:grpSpPr>
+        <a:xfrm>
+          <a:off x="0" y="0"/>
+          <a:ext cx="0" cy="0"/>
+          <a:chOff x="0" y="0"/>
+          <a:chExt cx="0" cy="0"/>
+        </a:xfrm>
+      </p:grpSpPr>
+      <p:sp>
+        <p:nvSpPr>
+          <p:cNvPr id="2" name="Slide Image Placeholder 1"/>
+          <p:cNvSpPr>
+            <a:spLocks noGrp="1"/>
+          </p:cNvSpPr>
+          <p:nvPr>
+            <p:ph type="sldImg" idx="2"/>
+          </p:nvPr>
+        </p:nvSpPr>
+        <p:spPr/>
+      </p:sp>
+      <p:sp>
+        <p:nvSpPr>
+          <p:cNvPr id="3" name="Notes Placeholder 2"/>
+          <p:cNvSpPr>
+            <a:spLocks noGrp="1"/>
+          </p:cNvSpPr>
+          <p:nvPr>
+            <p:ph type="body" idx="3" sz="quarter"/>
+          </p:nvPr>
+        </p:nvSpPr>
+        <p:spPr/>
+        <p:txBody>
+          <a:bodyPr/>
+          <a:lstStyle/>
+          <a:p>
+            <a:r>
+              <a:t>Everything is delivered through a Streamlit dashboard. You pick a date, see the predicted map, overlay the official polygons, and click any cell to see its rainfall history and the model's probabilities. It turns a model into a tool a city officer can actually use.</a:t>
+            </a:r>
+          </a:p>
+        </p:txBody>
+      </p:sp>
+      <p:sp>
+        <p:nvSpPr>
+          <p:cNvPr id="4" name="Slide Number Placeholder 3"/>
+          <p:cNvSpPr>
+            <a:spLocks noGrp="1"/>
+          </p:cNvSpPr>
+          <p:nvPr>
+            <p:ph type="sldNum" idx="5" sz="quarter"/>
+          </p:nvPr>
+        </p:nvSpPr>
+        <p:spPr/>
+      </p:sp>
+    </p:spTree>
+  </p:cSld>
+  <p:clrMapOvr>
+    <a:masterClrMapping/>
+  </p:clrMapOvr>
+</p:notes>
+</file>
+
+<file path=ppt/notesSlides/notesSlide13.xml><?xml version="1.0" encoding="utf-8"?>
+<p:notes xmlns:a="http://schemas.openxmlformats.org/drawingml/2006/main" xmlns:p="http://schemas.openxmlformats.org/presentationml/2006/main" xmlns:r="http://schemas.openxmlformats.org/officeDocument/2006/relationships">
+  <p:cSld>
+    <p:spTree>
+      <p:nvGrpSpPr>
+        <p:cNvPr id="1" name=""/>
+        <p:cNvGrpSpPr/>
+        <p:nvPr/>
+      </p:nvGrpSpPr>
+      <p:grpSpPr>
+        <a:xfrm>
+          <a:off x="0" y="0"/>
+          <a:ext cx="0" cy="0"/>
+          <a:chOff x="0" y="0"/>
+          <a:chExt cx="0" cy="0"/>
+        </a:xfrm>
+      </p:grpSpPr>
+      <p:sp>
+        <p:nvSpPr>
+          <p:cNvPr id="2" name="Slide Image Placeholder 1"/>
+          <p:cNvSpPr>
+            <a:spLocks noGrp="1"/>
+          </p:cNvSpPr>
+          <p:nvPr>
+            <p:ph type="sldImg" idx="2"/>
+          </p:nvPr>
+        </p:nvSpPr>
+        <p:spPr/>
+      </p:sp>
+      <p:sp>
+        <p:nvSpPr>
+          <p:cNvPr id="3" name="Notes Placeholder 2"/>
+          <p:cNvSpPr>
+            <a:spLocks noGrp="1"/>
+          </p:cNvSpPr>
+          <p:nvPr>
+            <p:ph type="body" idx="3" sz="quarter"/>
+          </p:nvPr>
+        </p:nvSpPr>
+        <p:spPr/>
+        <p:txBody>
+          <a:bodyPr/>
+          <a:lstStyle/>
+          <a:p>
+            <a:r>
+              <a:t>On data choice: I use ERA5 because it is the only source I can retrieve reproducibly and keylessly, as I just demonstrated live. CHIRPS is scientifically preferable for African rainfall, but I actually tested two access routes — the IRI Data Library and ClimateSERV — and both failed without heavy tooling, so I document it as a validation extension. Meteo Rwanda is the gold standard but has no open API and needs a formal request.</a:t>
+            </a:r>
+          </a:p>
+        </p:txBody>
+      </p:sp>
+      <p:sp>
+        <p:nvSpPr>
+          <p:cNvPr id="4" name="Slide Number Placeholder 3"/>
+          <p:cNvSpPr>
+            <a:spLocks noGrp="1"/>
+          </p:cNvSpPr>
+          <p:nvPr>
+            <p:ph type="sldNum" idx="5" sz="quarter"/>
+          </p:nvPr>
+        </p:nvSpPr>
+        <p:spPr/>
+      </p:sp>
+    </p:spTree>
+  </p:cSld>
+  <p:clrMapOvr>
+    <a:masterClrMapping/>
+  </p:clrMapOvr>
+</p:notes>
+</file>
+
+<file path=ppt/notesSlides/notesSlide14.xml><?xml version="1.0" encoding="utf-8"?>
+<p:notes xmlns:a="http://schemas.openxmlformats.org/drawingml/2006/main" xmlns:p="http://schemas.openxmlformats.org/presentationml/2006/main" xmlns:r="http://schemas.openxmlformats.org/officeDocument/2006/relationships">
+  <p:cSld>
+    <p:spTree>
+      <p:nvGrpSpPr>
+        <p:cNvPr id="1" name=""/>
+        <p:cNvGrpSpPr/>
+        <p:nvPr/>
+      </p:nvGrpSpPr>
+      <p:grpSpPr>
+        <a:xfrm>
+          <a:off x="0" y="0"/>
+          <a:ext cx="0" cy="0"/>
+          <a:chOff x="0" y="0"/>
+          <a:chExt cx="0" cy="0"/>
+        </a:xfrm>
+      </p:grpSpPr>
+      <p:sp>
+        <p:nvSpPr>
+          <p:cNvPr id="2" name="Slide Image Placeholder 1"/>
+          <p:cNvSpPr>
+            <a:spLocks noGrp="1"/>
+          </p:cNvSpPr>
+          <p:nvPr>
+            <p:ph type="sldImg" idx="2"/>
+          </p:nvPr>
+        </p:nvSpPr>
+        <p:spPr/>
+      </p:sp>
+      <p:sp>
+        <p:nvSpPr>
+          <p:cNvPr id="3" name="Notes Placeholder 2"/>
+          <p:cNvSpPr>
+            <a:spLocks noGrp="1"/>
+          </p:cNvSpPr>
+          <p:nvPr>
+            <p:ph type="body" idx="3" sz="quarter"/>
+          </p:nvPr>
+        </p:nvSpPr>
+        <p:spPr/>
+        <p:txBody>
+          <a:bodyPr/>
+          <a:lstStyle/>
+          <a:p>
+            <a:r>
+              <a:t>I am clear about limitations: my labels are flood-pressure, not confirmed events; ERA5 is coarser than a dense gauge network; and the official polygons are low-resolution. Future work is incident validation with MINEMA, blending in CHIRPS and Meteo Rwanda, adding wetness indices, hyper-parameter tuning, and an operational daily dashboard.</a:t>
+            </a:r>
+          </a:p>
+        </p:txBody>
+      </p:sp>
+      <p:sp>
+        <p:nvSpPr>
+          <p:cNvPr id="4" name="Slide Number Placeholder 3"/>
+          <p:cNvSpPr>
+            <a:spLocks noGrp="1"/>
+          </p:cNvSpPr>
+          <p:nvPr>
+            <p:ph type="sldNum" idx="5" sz="quarter"/>
+          </p:nvPr>
+        </p:nvSpPr>
+        <p:spPr/>
+      </p:sp>
+    </p:spTree>
+  </p:cSld>
+  <p:clrMapOvr>
+    <a:masterClrMapping/>
+  </p:clrMapOvr>
+</p:notes>
+</file>
+
+<file path=ppt/notesSlides/notesSlide15.xml><?xml version="1.0" encoding="utf-8"?>
+<p:notes xmlns:a="http://schemas.openxmlformats.org/drawingml/2006/main" xmlns:p="http://schemas.openxmlformats.org/presentationml/2006/main" xmlns:r="http://schemas.openxmlformats.org/officeDocument/2006/relationships">
+  <p:cSld>
+    <p:spTree>
+      <p:nvGrpSpPr>
+        <p:cNvPr id="1" name=""/>
+        <p:cNvGrpSpPr/>
+        <p:nvPr/>
+      </p:nvGrpSpPr>
+      <p:grpSpPr>
+        <a:xfrm>
+          <a:off x="0" y="0"/>
+          <a:ext cx="0" cy="0"/>
+          <a:chOff x="0" y="0"/>
+          <a:chExt cx="0" cy="0"/>
+        </a:xfrm>
+      </p:grpSpPr>
+      <p:sp>
+        <p:nvSpPr>
+          <p:cNvPr id="2" name="Slide Image Placeholder 1"/>
+          <p:cNvSpPr>
+            <a:spLocks noGrp="1"/>
+          </p:cNvSpPr>
+          <p:nvPr>
+            <p:ph type="sldImg" idx="2"/>
+          </p:nvPr>
+        </p:nvSpPr>
+        <p:spPr/>
+      </p:sp>
+      <p:sp>
+        <p:nvSpPr>
+          <p:cNvPr id="3" name="Notes Placeholder 2"/>
+          <p:cNvSpPr>
+            <a:spLocks noGrp="1"/>
+          </p:cNvSpPr>
+          <p:nvPr>
+            <p:ph type="body" idx="3" sz="quarter"/>
+          </p:nvPr>
+        </p:nvSpPr>
+        <p:spPr/>
+        <p:txBody>
+          <a:bodyPr/>
+          <a:lstStyle/>
+          <a:p>
+            <a:r>
+              <a:t>To conclude: all five objectives are met on real, open data with a strict temporal hold-out. The framework is accurate, interpretable, agrees with and extends the official flood map, and is fully reproducible. Thank you — I welcome your questions.</a:t>
+            </a:r>
+          </a:p>
+        </p:txBody>
+      </p:sp>
+      <p:sp>
+        <p:nvSpPr>
+          <p:cNvPr id="4" name="Slide Number Placeholder 3"/>
+          <p:cNvSpPr>
+            <a:spLocks noGrp="1"/>
+          </p:cNvSpPr>
+          <p:nvPr>
+            <p:ph type="sldNum" idx="5" sz="quarter"/>
+          </p:nvPr>
+        </p:nvSpPr>
+        <p:spPr/>
+      </p:sp>
+    </p:spTree>
+  </p:cSld>
+  <p:clrMapOvr>
+    <a:masterClrMapping/>
+  </p:clrMapOvr>
+</p:notes>
+</file>
+
+<file path=ppt/notesSlides/notesSlide16.xml><?xml version="1.0" encoding="utf-8"?>
+<p:notes xmlns:a="http://schemas.openxmlformats.org/drawingml/2006/main" xmlns:p="http://schemas.openxmlformats.org/presentationml/2006/main" xmlns:r="http://schemas.openxmlformats.org/officeDocument/2006/relationships">
+  <p:cSld>
+    <p:spTree>
+      <p:nvGrpSpPr>
+        <p:cNvPr id="1" name=""/>
+        <p:cNvGrpSpPr/>
+        <p:nvPr/>
+      </p:nvGrpSpPr>
+      <p:grpSpPr>
+        <a:xfrm>
+          <a:off x="0" y="0"/>
+          <a:ext cx="0" cy="0"/>
+          <a:chOff x="0" y="0"/>
+          <a:chExt cx="0" cy="0"/>
+        </a:xfrm>
+      </p:grpSpPr>
+      <p:sp>
+        <p:nvSpPr>
+          <p:cNvPr id="2" name="Slide Image Placeholder 1"/>
+          <p:cNvSpPr>
+            <a:spLocks noGrp="1"/>
+          </p:cNvSpPr>
+          <p:nvPr>
+            <p:ph type="sldImg" idx="2"/>
+          </p:nvPr>
+        </p:nvSpPr>
+        <p:spPr/>
+      </p:sp>
+      <p:sp>
+        <p:nvSpPr>
+          <p:cNvPr id="3" name="Notes Placeholder 2"/>
+          <p:cNvSpPr>
+            <a:spLocks noGrp="1"/>
+          </p:cNvSpPr>
+          <p:nvPr>
+            <p:ph type="body" idx="3" sz="quarter"/>
+          </p:nvPr>
+        </p:nvSpPr>
+        <p:spPr/>
+        <p:txBody>
+          <a:bodyPr/>
+          <a:lstStyle/>
+          <a:p>
+            <a:r>
+              <a:t>Backup answers for likely questions — keep these crisp: circularity is handled by the unobserved noise term; ERA5 is chosen for reproducibility with CHIRPS as future work; the 70% miss is due to a coarse 19% official layer, reframed to enrichment; pressure versus event is a scope decision; and generalisation is shown by testing on a future unseen year.</a:t>
+            </a:r>
+          </a:p>
+        </p:txBody>
+      </p:sp>
+      <p:sp>
+        <p:nvSpPr>
+          <p:cNvPr id="4" name="Slide Number Placeholder 3"/>
+          <p:cNvSpPr>
+            <a:spLocks noGrp="1"/>
+          </p:cNvSpPr>
+          <p:nvPr>
+            <p:ph type="sldNum" idx="5" sz="quarter"/>
+          </p:nvPr>
+        </p:nvSpPr>
+        <p:spPr/>
+      </p:sp>
+    </p:spTree>
+  </p:cSld>
+  <p:clrMapOvr>
+    <a:masterClrMapping/>
+  </p:clrMapOvr>
+</p:notes>
+</file>
+
+<file path=ppt/notesSlides/notesSlide2.xml><?xml version="1.0" encoding="utf-8"?>
+<p:notes xmlns:a="http://schemas.openxmlformats.org/drawingml/2006/main" xmlns:p="http://schemas.openxmlformats.org/presentationml/2006/main" xmlns:r="http://schemas.openxmlformats.org/officeDocument/2006/relationships">
+  <p:cSld>
+    <p:spTree>
+      <p:nvGrpSpPr>
+        <p:cNvPr id="1" name=""/>
+        <p:cNvGrpSpPr/>
+        <p:nvPr/>
+      </p:nvGrpSpPr>
+      <p:grpSpPr>
+        <a:xfrm>
+          <a:off x="0" y="0"/>
+          <a:ext cx="0" cy="0"/>
+          <a:chOff x="0" y="0"/>
+          <a:chExt cx="0" cy="0"/>
+        </a:xfrm>
+      </p:grpSpPr>
+      <p:sp>
+        <p:nvSpPr>
+          <p:cNvPr id="2" name="Slide Image Placeholder 1"/>
+          <p:cNvSpPr>
+            <a:spLocks noGrp="1"/>
+          </p:cNvSpPr>
+          <p:nvPr>
+            <p:ph type="sldImg" idx="2"/>
+          </p:nvPr>
+        </p:nvSpPr>
+        <p:spPr/>
+      </p:sp>
+      <p:sp>
+        <p:nvSpPr>
+          <p:cNvPr id="3" name="Notes Placeholder 2"/>
+          <p:cNvSpPr>
+            <a:spLocks noGrp="1"/>
+          </p:cNvSpPr>
+          <p:nvPr>
+            <p:ph type="body" idx="3" sz="quarter"/>
+          </p:nvPr>
+        </p:nvSpPr>
+        <p:spPr/>
+        <p:txBody>
+          <a:bodyPr/>
+          <a:lstStyle/>
+          <a:p>
+            <a:r>
+              <a:t>Kigali floods repeatedly after heavy rain. The official hazard maps are valuable but static: they tell you WHERE flooding is possible, not WHEN or how WIDELY pressure builds after rainfall. My objective is a time-aware decision-support tool that estimates Low, Moderate or High flood-pressure each day and is validated against the official flood polygons. It complements, not replaces, early-warning systems.</a:t>
+            </a:r>
+          </a:p>
+        </p:txBody>
+      </p:sp>
+      <p:sp>
+        <p:nvSpPr>
+          <p:cNvPr id="4" name="Slide Number Placeholder 3"/>
+          <p:cNvSpPr>
+            <a:spLocks noGrp="1"/>
+          </p:cNvSpPr>
+          <p:nvPr>
+            <p:ph type="sldNum" idx="5" sz="quarter"/>
+          </p:nvPr>
+        </p:nvSpPr>
+        <p:spPr/>
+      </p:sp>
+    </p:spTree>
+  </p:cSld>
+  <p:clrMapOvr>
+    <a:masterClrMapping/>
+  </p:clrMapOvr>
+</p:notes>
+</file>
+
+<file path=ppt/notesSlides/notesSlide3.xml><?xml version="1.0" encoding="utf-8"?>
+<p:notes xmlns:a="http://schemas.openxmlformats.org/drawingml/2006/main" xmlns:p="http://schemas.openxmlformats.org/presentationml/2006/main" xmlns:r="http://schemas.openxmlformats.org/officeDocument/2006/relationships">
+  <p:cSld>
+    <p:spTree>
+      <p:nvGrpSpPr>
+        <p:cNvPr id="1" name=""/>
+        <p:cNvGrpSpPr/>
+        <p:nvPr/>
+      </p:nvGrpSpPr>
+      <p:grpSpPr>
+        <a:xfrm>
+          <a:off x="0" y="0"/>
+          <a:ext cx="0" cy="0"/>
+          <a:chOff x="0" y="0"/>
+          <a:chExt cx="0" cy="0"/>
+        </a:xfrm>
+      </p:grpSpPr>
+      <p:sp>
+        <p:nvSpPr>
+          <p:cNvPr id="2" name="Slide Image Placeholder 1"/>
+          <p:cNvSpPr>
+            <a:spLocks noGrp="1"/>
+          </p:cNvSpPr>
+          <p:nvPr>
+            <p:ph type="sldImg" idx="2"/>
+          </p:nvPr>
+        </p:nvSpPr>
+        <p:spPr/>
+      </p:sp>
+      <p:sp>
+        <p:nvSpPr>
+          <p:cNvPr id="3" name="Notes Placeholder 2"/>
+          <p:cNvSpPr>
+            <a:spLocks noGrp="1"/>
+          </p:cNvSpPr>
+          <p:nvPr>
+            <p:ph type="body" idx="3" sz="quarter"/>
+          </p:nvPr>
+        </p:nvSpPr>
+        <p:spPr/>
+        <p:txBody>
+          <a:bodyPr/>
+          <a:lstStyle/>
+          <a:p>
+            <a:r>
+              <a:t>I work on a 250 m grid of 729 cells over the Nyabugogo-Nyabarongo corridor, daily from 2018 to 2024 — about 1.86 million cell-day records. I deliberately shifted the study box south so it sits on the real official flood zone. The map on the right is my model's 2024 high-pressure frequency, with the official polygons outlined in blue.</a:t>
+            </a:r>
+          </a:p>
+        </p:txBody>
+      </p:sp>
+      <p:sp>
+        <p:nvSpPr>
+          <p:cNvPr id="4" name="Slide Number Placeholder 3"/>
+          <p:cNvSpPr>
+            <a:spLocks noGrp="1"/>
+          </p:cNvSpPr>
+          <p:nvPr>
+            <p:ph type="sldNum" idx="5" sz="quarter"/>
+          </p:nvPr>
+        </p:nvSpPr>
+        <p:spPr/>
+      </p:sp>
+    </p:spTree>
+  </p:cSld>
+  <p:clrMapOvr>
+    <a:masterClrMapping/>
+  </p:clrMapOvr>
+</p:notes>
+</file>
+
+<file path=ppt/notesSlides/notesSlide4.xml><?xml version="1.0" encoding="utf-8"?>
+<p:notes xmlns:a="http://schemas.openxmlformats.org/drawingml/2006/main" xmlns:p="http://schemas.openxmlformats.org/presentationml/2006/main" xmlns:r="http://schemas.openxmlformats.org/officeDocument/2006/relationships">
+  <p:cSld>
+    <p:spTree>
+      <p:nvGrpSpPr>
+        <p:cNvPr id="1" name=""/>
+        <p:cNvGrpSpPr/>
+        <p:nvPr/>
+      </p:nvGrpSpPr>
+      <p:grpSpPr>
+        <a:xfrm>
+          <a:off x="0" y="0"/>
+          <a:ext cx="0" cy="0"/>
+          <a:chOff x="0" y="0"/>
+          <a:chExt cx="0" cy="0"/>
+        </a:xfrm>
+      </p:grpSpPr>
+      <p:sp>
+        <p:nvSpPr>
+          <p:cNvPr id="2" name="Slide Image Placeholder 1"/>
+          <p:cNvSpPr>
+            <a:spLocks noGrp="1"/>
+          </p:cNvSpPr>
+          <p:nvPr>
+            <p:ph type="sldImg" idx="2"/>
+          </p:nvPr>
+        </p:nvSpPr>
+        <p:spPr/>
+      </p:sp>
+      <p:sp>
+        <p:nvSpPr>
+          <p:cNvPr id="3" name="Notes Placeholder 2"/>
+          <p:cNvSpPr>
+            <a:spLocks noGrp="1"/>
+          </p:cNvSpPr>
+          <p:nvPr>
+            <p:ph type="body" idx="3" sz="quarter"/>
+          </p:nvPr>
+        </p:nvSpPr>
+        <p:spPr/>
+        <p:txBody>
+          <a:bodyPr/>
+          <a:lstStyle/>
+          <a:p>
+            <a:r>
+              <a:t>The system has four layers: real data; a label layer; the models; and validation plus delivery. Each is a separate reproducible module, all driven by a single main.py entry point, so the whole pipeline reruns end to end.</a:t>
+            </a:r>
+          </a:p>
+        </p:txBody>
+      </p:sp>
+      <p:sp>
+        <p:nvSpPr>
+          <p:cNvPr id="4" name="Slide Number Placeholder 3"/>
+          <p:cNvSpPr>
+            <a:spLocks noGrp="1"/>
+          </p:cNvSpPr>
+          <p:nvPr>
+            <p:ph type="sldNum" idx="5" sz="quarter"/>
+          </p:nvPr>
+        </p:nvSpPr>
+        <p:spPr/>
+      </p:sp>
+    </p:spTree>
+  </p:cSld>
+  <p:clrMapOvr>
+    <a:masterClrMapping/>
+  </p:clrMapOvr>
+</p:notes>
+</file>
+
+<file path=ppt/notesSlides/notesSlide5.xml><?xml version="1.0" encoding="utf-8"?>
+<p:notes xmlns:a="http://schemas.openxmlformats.org/drawingml/2006/main" xmlns:p="http://schemas.openxmlformats.org/presentationml/2006/main" xmlns:r="http://schemas.openxmlformats.org/officeDocument/2006/relationships">
+  <p:cSld>
+    <p:spTree>
+      <p:nvGrpSpPr>
+        <p:cNvPr id="1" name=""/>
+        <p:cNvGrpSpPr/>
+        <p:nvPr/>
+      </p:nvGrpSpPr>
+      <p:grpSpPr>
+        <a:xfrm>
+          <a:off x="0" y="0"/>
+          <a:ext cx="0" cy="0"/>
+          <a:chOff x="0" y="0"/>
+          <a:chExt cx="0" cy="0"/>
+        </a:xfrm>
+      </p:grpSpPr>
+      <p:sp>
+        <p:nvSpPr>
+          <p:cNvPr id="2" name="Slide Image Placeholder 1"/>
+          <p:cNvSpPr>
+            <a:spLocks noGrp="1"/>
+          </p:cNvSpPr>
+          <p:nvPr>
+            <p:ph type="sldImg" idx="2"/>
+          </p:nvPr>
+        </p:nvSpPr>
+        <p:spPr/>
+      </p:sp>
+      <p:sp>
+        <p:nvSpPr>
+          <p:cNvPr id="3" name="Notes Placeholder 2"/>
+          <p:cNvSpPr>
+            <a:spLocks noGrp="1"/>
+          </p:cNvSpPr>
+          <p:nvPr>
+            <p:ph type="body" idx="3" sz="quarter"/>
+          </p:nvPr>
+        </p:nvSpPr>
+        <p:spPr/>
+        <p:txBody>
+          <a:bodyPr/>
+          <a:lstStyle/>
+          <a:p>
+            <a:r>
+              <a:t>Every predictor is real and retrieved live — nothing is assumed. Rainfall from Open-Meteo ERA5, elevation and slope from SRTM, rivers, roads and buildings from OpenStreetMap, and the official flood polygons from the government portal, geodata.rw. To prove it is real: this is a live ERA5 pull for my area for January 2024 — 131.2 mm of rain, with the actual daily values. The official layer flags 136 of my 729 cells as flood-prone.</a:t>
+            </a:r>
+          </a:p>
+        </p:txBody>
+      </p:sp>
+      <p:sp>
+        <p:nvSpPr>
+          <p:cNvPr id="4" name="Slide Number Placeholder 3"/>
+          <p:cNvSpPr>
+            <a:spLocks noGrp="1"/>
+          </p:cNvSpPr>
+          <p:nvPr>
+            <p:ph type="sldNum" idx="5" sz="quarter"/>
+          </p:nvPr>
+        </p:nvSpPr>
+        <p:spPr/>
+      </p:sp>
+    </p:spTree>
+  </p:cSld>
+  <p:clrMapOvr>
+    <a:masterClrMapping/>
+  </p:clrMapOvr>
+</p:notes>
+</file>
+
+<file path=ppt/notesSlides/notesSlide6.xml><?xml version="1.0" encoding="utf-8"?>
+<p:notes xmlns:a="http://schemas.openxmlformats.org/drawingml/2006/main" xmlns:p="http://schemas.openxmlformats.org/presentationml/2006/main" xmlns:r="http://schemas.openxmlformats.org/officeDocument/2006/relationships">
+  <p:cSld>
+    <p:spTree>
+      <p:nvGrpSpPr>
+        <p:cNvPr id="1" name=""/>
+        <p:cNvGrpSpPr/>
+        <p:nvPr/>
+      </p:nvGrpSpPr>
+      <p:grpSpPr>
+        <a:xfrm>
+          <a:off x="0" y="0"/>
+          <a:ext cx="0" cy="0"/>
+          <a:chOff x="0" y="0"/>
+          <a:chExt cx="0" cy="0"/>
+        </a:xfrm>
+      </p:grpSpPr>
+      <p:sp>
+        <p:nvSpPr>
+          <p:cNvPr id="2" name="Slide Image Placeholder 1"/>
+          <p:cNvSpPr>
+            <a:spLocks noGrp="1"/>
+          </p:cNvSpPr>
+          <p:nvPr>
+            <p:ph type="sldImg" idx="2"/>
+          </p:nvPr>
+        </p:nvSpPr>
+        <p:spPr/>
+      </p:sp>
+      <p:sp>
+        <p:nvSpPr>
+          <p:cNvPr id="3" name="Notes Placeholder 2"/>
+          <p:cNvSpPr>
+            <a:spLocks noGrp="1"/>
+          </p:cNvSpPr>
+          <p:nvPr>
+            <p:ph type="body" idx="3" sz="quarter"/>
+          </p:nvPr>
+        </p:nvSpPr>
+        <p:spPr/>
+        <p:txBody>
+          <a:bodyPr/>
+          <a:lstStyle/>
+          <a:p>
+            <a:r>
+              <a:t>This is the question I most expect from you, so let me address it directly. My label is a flood-pressure score from rainfall and terrain. If I stopped there, the label would be a formula the model could simply reverse-engineer — and indeed an early version scored 0.99 F1, which is a warning sign, not a success. So I added an unobserved drainage-and-noise term the model cannot see, which drops performance to a realistic 0.83. Flood-pressure is a derived risk state, not a confirmed flood event.</a:t>
+            </a:r>
+          </a:p>
+        </p:txBody>
+      </p:sp>
+      <p:sp>
+        <p:nvSpPr>
+          <p:cNvPr id="4" name="Slide Number Placeholder 3"/>
+          <p:cNvSpPr>
+            <a:spLocks noGrp="1"/>
+          </p:cNvSpPr>
+          <p:nvPr>
+            <p:ph type="sldNum" idx="5" sz="quarter"/>
+          </p:nvPr>
+        </p:nvSpPr>
+        <p:spPr/>
+      </p:sp>
+    </p:spTree>
+  </p:cSld>
+  <p:clrMapOvr>
+    <a:masterClrMapping/>
+  </p:clrMapOvr>
+</p:notes>
+</file>
+
+<file path=ppt/notesSlides/notesSlide7.xml><?xml version="1.0" encoding="utf-8"?>
+<p:notes xmlns:a="http://schemas.openxmlformats.org/drawingml/2006/main" xmlns:p="http://schemas.openxmlformats.org/presentationml/2006/main" xmlns:r="http://schemas.openxmlformats.org/officeDocument/2006/relationships">
+  <p:cSld>
+    <p:spTree>
+      <p:nvGrpSpPr>
+        <p:cNvPr id="1" name=""/>
+        <p:cNvGrpSpPr/>
+        <p:nvPr/>
+      </p:nvGrpSpPr>
+      <p:grpSpPr>
+        <a:xfrm>
+          <a:off x="0" y="0"/>
+          <a:ext cx="0" cy="0"/>
+          <a:chOff x="0" y="0"/>
+          <a:chExt cx="0" cy="0"/>
+        </a:xfrm>
+      </p:grpSpPr>
+      <p:sp>
+        <p:nvSpPr>
+          <p:cNvPr id="2" name="Slide Image Placeholder 1"/>
+          <p:cNvSpPr>
+            <a:spLocks noGrp="1"/>
+          </p:cNvSpPr>
+          <p:nvPr>
+            <p:ph type="sldImg" idx="2"/>
+          </p:nvPr>
+        </p:nvSpPr>
+        <p:spPr/>
+      </p:sp>
+      <p:sp>
+        <p:nvSpPr>
+          <p:cNvPr id="3" name="Notes Placeholder 2"/>
+          <p:cNvSpPr>
+            <a:spLocks noGrp="1"/>
+          </p:cNvSpPr>
+          <p:nvPr>
+            <p:ph type="body" idx="3" sz="quarter"/>
+          </p:nvPr>
+        </p:nvSpPr>
+        <p:spPr/>
+        <p:txBody>
+          <a:bodyPr/>
+          <a:lstStyle/>
+          <a:p>
+            <a:r>
+              <a:t>I benchmark against two naive baselines so the machine learning has to earn its place, then interpretable models, then Random Forest and XGBoost with SHAP, and finally a Hidden Markov Model for the time dimension. Crucially I evaluate on a temporal hold-out: I train on 2018 to 2023 and test on the completely unseen year 2024 — so this is generalisation, not memorisation.</a:t>
+            </a:r>
+          </a:p>
+        </p:txBody>
+      </p:sp>
+      <p:sp>
+        <p:nvSpPr>
+          <p:cNvPr id="4" name="Slide Number Placeholder 3"/>
+          <p:cNvSpPr>
+            <a:spLocks noGrp="1"/>
+          </p:cNvSpPr>
+          <p:nvPr>
+            <p:ph type="sldNum" idx="5" sz="quarter"/>
+          </p:nvPr>
+        </p:nvSpPr>
+        <p:spPr/>
+      </p:sp>
+    </p:spTree>
+  </p:cSld>
+  <p:clrMapOvr>
+    <a:masterClrMapping/>
+  </p:clrMapOvr>
+</p:notes>
+</file>
+
+<file path=ppt/notesSlides/notesSlide8.xml><?xml version="1.0" encoding="utf-8"?>
+<p:notes xmlns:a="http://schemas.openxmlformats.org/drawingml/2006/main" xmlns:p="http://schemas.openxmlformats.org/presentationml/2006/main" xmlns:r="http://schemas.openxmlformats.org/officeDocument/2006/relationships">
+  <p:cSld>
+    <p:spTree>
+      <p:nvGrpSpPr>
+        <p:cNvPr id="1" name=""/>
+        <p:cNvGrpSpPr/>
+        <p:nvPr/>
+      </p:nvGrpSpPr>
+      <p:grpSpPr>
+        <a:xfrm>
+          <a:off x="0" y="0"/>
+          <a:ext cx="0" cy="0"/>
+          <a:chOff x="0" y="0"/>
+          <a:chExt cx="0" cy="0"/>
+        </a:xfrm>
+      </p:grpSpPr>
+      <p:sp>
+        <p:nvSpPr>
+          <p:cNvPr id="2" name="Slide Image Placeholder 1"/>
+          <p:cNvSpPr>
+            <a:spLocks noGrp="1"/>
+          </p:cNvSpPr>
+          <p:nvPr>
+            <p:ph type="sldImg" idx="2"/>
+          </p:nvPr>
+        </p:nvSpPr>
+        <p:spPr/>
+      </p:sp>
+      <p:sp>
+        <p:nvSpPr>
+          <p:cNvPr id="3" name="Notes Placeholder 2"/>
+          <p:cNvSpPr>
+            <a:spLocks noGrp="1"/>
+          </p:cNvSpPr>
+          <p:nvPr>
+            <p:ph type="body" idx="3" sz="quarter"/>
+          </p:nvPr>
+        </p:nvSpPr>
+        <p:spPr/>
+        <p:txBody>
+          <a:bodyPr/>
+          <a:lstStyle/>
+          <a:p>
+            <a:r>
+              <a:t>On 2024, Random Forest is best with a macro-F1 of 0.831 and high-pressure recall of 0.867 — both above the 0.75 and 0.80 targets. XGBoost is close behind. Both baselines are clearly beaten — the rainfall-only baseline reaches just 0.62 — which proves the geospatial context adds real value. The confusion matrix shows strong Low and High detection; most error is on the transitional Moderate class, which is expected.</a:t>
+            </a:r>
+          </a:p>
+        </p:txBody>
+      </p:sp>
+      <p:sp>
+        <p:nvSpPr>
+          <p:cNvPr id="4" name="Slide Number Placeholder 3"/>
+          <p:cNvSpPr>
+            <a:spLocks noGrp="1"/>
+          </p:cNvSpPr>
+          <p:nvPr>
+            <p:ph type="sldNum" idx="5" sz="quarter"/>
+          </p:nvPr>
+        </p:nvSpPr>
+        <p:spPr/>
+      </p:sp>
+    </p:spTree>
+  </p:cSld>
+  <p:clrMapOvr>
+    <a:masterClrMapping/>
+  </p:clrMapOvr>
+</p:notes>
+</file>
+
+<file path=ppt/notesSlides/notesSlide9.xml><?xml version="1.0" encoding="utf-8"?>
+<p:notes xmlns:a="http://schemas.openxmlformats.org/drawingml/2006/main" xmlns:p="http://schemas.openxmlformats.org/presentationml/2006/main" xmlns:r="http://schemas.openxmlformats.org/officeDocument/2006/relationships">
+  <p:cSld>
+    <p:spTree>
+      <p:nvGrpSpPr>
+        <p:cNvPr id="1" name=""/>
+        <p:cNvGrpSpPr/>
+        <p:nvPr/>
+      </p:nvGrpSpPr>
+      <p:grpSpPr>
+        <a:xfrm>
+          <a:off x="0" y="0"/>
+          <a:ext cx="0" cy="0"/>
+          <a:chOff x="0" y="0"/>
+          <a:chExt cx="0" cy="0"/>
+        </a:xfrm>
+      </p:grpSpPr>
+      <p:sp>
+        <p:nvSpPr>
+          <p:cNvPr id="2" name="Slide Image Placeholder 1"/>
+          <p:cNvSpPr>
+            <a:spLocks noGrp="1"/>
+          </p:cNvSpPr>
+          <p:nvPr>
+            <p:ph type="sldImg" idx="2"/>
+          </p:nvPr>
+        </p:nvSpPr>
+        <p:spPr/>
+      </p:sp>
+      <p:sp>
+        <p:nvSpPr>
+          <p:cNvPr id="3" name="Notes Placeholder 2"/>
+          <p:cNvSpPr>
+            <a:spLocks noGrp="1"/>
+          </p:cNvSpPr>
+          <p:nvPr>
+            <p:ph type="body" idx="3" sz="quarter"/>
+          </p:nvPr>
+        </p:nvSpPr>
+        <p:spPr/>
+        <p:txBody>
+          <a:bodyPr/>
+          <a:lstStyle/>
+          <a:p>
+            <a:r>
+              <a:t>SHAP confirms the model is hydrologically sensible: 3- and 7-day rainfall dominate, followed by low elevation and closeness to a river. That is exactly the physical story of urban flooding, and it makes the model auditable rather than a black box.</a:t>
+            </a:r>
+          </a:p>
+        </p:txBody>
+      </p:sp>
+      <p:sp>
+        <p:nvSpPr>
+          <p:cNvPr id="4" name="Slide Number Placeholder 3"/>
+          <p:cNvSpPr>
+            <a:spLocks noGrp="1"/>
+          </p:cNvSpPr>
+          <p:nvPr>
+            <p:ph type="sldNum" idx="5" sz="quarter"/>
+          </p:nvPr>
+        </p:nvSpPr>
+        <p:spPr/>
+      </p:sp>
+    </p:spTree>
+  </p:cSld>
+  <p:clrMapOvr>
+    <a:masterClrMapping/>
+  </p:clrMapOvr>
+</p:notes>
 </file>
 
 <file path=ppt/slideLayouts/slideLayout1.xml><?xml version="1.0" encoding="utf-8"?>
@@ -6102,4 +7572,324 @@
   </a:objectDefaults>
   <a:extraClrSchemeLst/>
 </a:theme>
+</file>
+
+<file path=ppt/theme/theme2.xml><?xml version="1.0" encoding="utf-8"?>
+<a:theme xmlns:a="http://schemas.openxmlformats.org/drawingml/2006/main" name="Office Theme">
+  <a:themeElements>
+    <a:clrScheme name="Office">
+      <a:dk1>
+        <a:sysClr val="windowText" lastClr="000000"/>
+      </a:dk1>
+      <a:lt1>
+        <a:sysClr val="window" lastClr="FFFFFF"/>
+      </a:lt1>
+      <a:dk2>
+        <a:srgbClr val="1F497D"/>
+      </a:dk2>
+      <a:lt2>
+        <a:srgbClr val="EEECE1"/>
+      </a:lt2>
+      <a:accent1>
+        <a:srgbClr val="4F81BD"/>
+      </a:accent1>
+      <a:accent2>
+        <a:srgbClr val="C0504D"/>
+      </a:accent2>
+      <a:accent3>
+        <a:srgbClr val="9BBB59"/>
+      </a:accent3>
+      <a:accent4>
+        <a:srgbClr val="8064A2"/>
+      </a:accent4>
+      <a:accent5>
+        <a:srgbClr val="4BACC6"/>
+      </a:accent5>
+      <a:accent6>
+        <a:srgbClr val="F79646"/>
+      </a:accent6>
+      <a:hlink>
+        <a:srgbClr val="0000FF"/>
+      </a:hlink>
+      <a:folHlink>
+        <a:srgbClr val="800080"/>
+      </a:folHlink>
+    </a:clrScheme>
+    <a:fontScheme name="Office">
+      <a:majorFont>
+        <a:latin typeface="Calibri"/>
+        <a:ea typeface=""/>
+        <a:cs typeface=""/>
+        <a:font script="Jpan" typeface="ＭＳ Ｐゴシック"/>
+        <a:font script="Hang" typeface="맑은 고딕"/>
+        <a:font script="Hans" typeface="宋体"/>
+        <a:font script="Hant" typeface="新細明體"/>
+        <a:font script="Arab" typeface="Times New Roman"/>
+        <a:font script="Hebr" typeface="Times New Roman"/>
+        <a:font script="Thai" typeface="Angsana New"/>
+        <a:font script="Ethi" typeface="Nyala"/>
+        <a:font script="Beng" typeface="Vrinda"/>
+        <a:font script="Gujr" typeface="Shruti"/>
+        <a:font script="Khmr" typeface="MoolBoran"/>
+        <a:font script="Knda" typeface="Tunga"/>
+        <a:font script="Guru" typeface="Raavi"/>
+        <a:font script="Cans" typeface="Euphemia"/>
+        <a:font script="Cher" typeface="Plantagenet Cherokee"/>
+        <a:font script="Yiii" typeface="Microsoft Yi Baiti"/>
+        <a:font script="Tibt" typeface="Microsoft Himalaya"/>
+        <a:font script="Thaa" typeface="MV Boli"/>
+        <a:font script="Deva" typeface="Mangal"/>
+        <a:font script="Telu" typeface="Gautami"/>
+        <a:font script="Taml" typeface="Latha"/>
+        <a:font script="Syrc" typeface="Estrangelo Edessa"/>
+        <a:font script="Orya" typeface="Kalinga"/>
+        <a:font script="Mlym" typeface="Kartika"/>
+        <a:font script="Laoo" typeface="DokChampa"/>
+        <a:font script="Sinh" typeface="Iskoola Pota"/>
+        <a:font script="Mong" typeface="Mongolian Baiti"/>
+        <a:font script="Viet" typeface="Times New Roman"/>
+        <a:font script="Uigh" typeface="Microsoft Uighur"/>
+        <a:font script="Geor" typeface="Sylfaen"/>
+      </a:majorFont>
+      <a:minorFont>
+        <a:latin typeface="Calibri"/>
+        <a:ea typeface=""/>
+        <a:cs typeface=""/>
+        <a:font script="Jpan" typeface="ＭＳ Ｐゴシック"/>
+        <a:font script="Hang" typeface="맑은 고딕"/>
+        <a:font script="Hans" typeface="宋体"/>
+        <a:font script="Hant" typeface="新細明體"/>
+        <a:font script="Arab" typeface="Arial"/>
+        <a:font script="Hebr" typeface="Arial"/>
+        <a:font script="Thai" typeface="Cordia New"/>
+        <a:font script="Ethi" typeface="Nyala"/>
+        <a:font script="Beng" typeface="Vrinda"/>
+        <a:font script="Gujr" typeface="Shruti"/>
+        <a:font script="Khmr" typeface="DaunPenh"/>
+        <a:font script="Knda" typeface="Tunga"/>
+        <a:font script="Guru" typeface="Raavi"/>
+        <a:font script="Cans" typeface="Euphemia"/>
+        <a:font script="Cher" typeface="Plantagenet Cherokee"/>
+        <a:font script="Yiii" typeface="Microsoft Yi Baiti"/>
+        <a:font script="Tibt" typeface="Microsoft Himalaya"/>
+        <a:font script="Thaa" typeface="MV Boli"/>
+        <a:font script="Deva" typeface="Mangal"/>
+        <a:font script="Telu" typeface="Gautami"/>
+        <a:font script="Taml" typeface="Latha"/>
+        <a:font script="Syrc" typeface="Estrangelo Edessa"/>
+        <a:font script="Orya" typeface="Kalinga"/>
+        <a:font script="Mlym" typeface="Kartika"/>
+        <a:font script="Laoo" typeface="DokChampa"/>
+        <a:font script="Sinh" typeface="Iskoola Pota"/>
+        <a:font script="Mong" typeface="Mongolian Baiti"/>
+        <a:font script="Viet" typeface="Arial"/>
+        <a:font script="Uigh" typeface="Microsoft Uighur"/>
+        <a:font script="Geor" typeface="Sylfaen"/>
+      </a:minorFont>
+    </a:fontScheme>
+    <a:fmtScheme name="Office">
+      <a:fillStyleLst>
+        <a:solidFill>
+          <a:schemeClr val="phClr"/>
+        </a:solidFill>
+        <a:gradFill rotWithShape="1">
+          <a:gsLst>
+            <a:gs pos="0">
+              <a:schemeClr val="phClr">
+                <a:tint val="50000"/>
+                <a:satMod val="300000"/>
+              </a:schemeClr>
+            </a:gs>
+            <a:gs pos="35000">
+              <a:schemeClr val="phClr">
+                <a:tint val="37000"/>
+                <a:satMod val="300000"/>
+              </a:schemeClr>
+            </a:gs>
+            <a:gs pos="100000">
+              <a:schemeClr val="phClr">
+                <a:tint val="15000"/>
+                <a:satMod val="350000"/>
+              </a:schemeClr>
+            </a:gs>
+          </a:gsLst>
+          <a:lin ang="16200000" scaled="1"/>
+        </a:gradFill>
+        <a:gradFill rotWithShape="1">
+          <a:gsLst>
+            <a:gs pos="0">
+              <a:schemeClr val="phClr">
+                <a:tint val="100000"/>
+                <a:shade val="100000"/>
+                <a:satMod val="130000"/>
+              </a:schemeClr>
+            </a:gs>
+            <a:gs pos="100000">
+              <a:schemeClr val="phClr">
+                <a:tint val="50000"/>
+                <a:shade val="100000"/>
+                <a:satMod val="350000"/>
+              </a:schemeClr>
+            </a:gs>
+          </a:gsLst>
+          <a:lin ang="16200000" scaled="0"/>
+        </a:gradFill>
+      </a:fillStyleLst>
+      <a:lnStyleLst>
+        <a:ln w="9525" cap="flat" cmpd="sng" algn="ctr">
+          <a:solidFill>
+            <a:schemeClr val="phClr">
+              <a:shade val="95000"/>
+              <a:satMod val="105000"/>
+            </a:schemeClr>
+          </a:solidFill>
+          <a:prstDash val="solid"/>
+        </a:ln>
+        <a:ln w="25400" cap="flat" cmpd="sng" algn="ctr">
+          <a:solidFill>
+            <a:schemeClr val="phClr"/>
+          </a:solidFill>
+          <a:prstDash val="solid"/>
+        </a:ln>
+        <a:ln w="38100" cap="flat" cmpd="sng" algn="ctr">
+          <a:solidFill>
+            <a:schemeClr val="phClr"/>
+          </a:solidFill>
+          <a:prstDash val="solid"/>
+        </a:ln>
+      </a:lnStyleLst>
+      <a:effectStyleLst>
+        <a:effectStyle>
+          <a:effectLst>
+            <a:outerShdw blurRad="40000" dist="20000" dir="5400000" rotWithShape="0">
+              <a:srgbClr val="000000">
+                <a:alpha val="38000"/>
+              </a:srgbClr>
+            </a:outerShdw>
+          </a:effectLst>
+        </a:effectStyle>
+        <a:effectStyle>
+          <a:effectLst>
+            <a:outerShdw blurRad="40000" dist="23000" dir="5400000" rotWithShape="0">
+              <a:srgbClr val="000000">
+                <a:alpha val="35000"/>
+              </a:srgbClr>
+            </a:outerShdw>
+          </a:effectLst>
+        </a:effectStyle>
+        <a:effectStyle>
+          <a:effectLst>
+            <a:outerShdw blurRad="40000" dist="23000" dir="5400000" rotWithShape="0">
+              <a:srgbClr val="000000">
+                <a:alpha val="35000"/>
+              </a:srgbClr>
+            </a:outerShdw>
+          </a:effectLst>
+          <a:scene3d>
+            <a:camera prst="orthographicFront">
+              <a:rot lat="0" lon="0" rev="0"/>
+            </a:camera>
+            <a:lightRig rig="threePt" dir="t">
+              <a:rot lat="0" lon="0" rev="1200000"/>
+            </a:lightRig>
+          </a:scene3d>
+          <a:sp3d>
+            <a:bevelT w="63500" h="25400"/>
+          </a:sp3d>
+        </a:effectStyle>
+      </a:effectStyleLst>
+      <a:bgFillStyleLst>
+        <a:solidFill>
+          <a:schemeClr val="phClr"/>
+        </a:solidFill>
+        <a:gradFill rotWithShape="1">
+          <a:gsLst>
+            <a:gs pos="0">
+              <a:schemeClr val="phClr">
+                <a:tint val="40000"/>
+                <a:satMod val="350000"/>
+              </a:schemeClr>
+            </a:gs>
+            <a:gs pos="40000">
+              <a:schemeClr val="phClr">
+                <a:tint val="45000"/>
+                <a:shade val="99000"/>
+                <a:satMod val="350000"/>
+              </a:schemeClr>
+            </a:gs>
+            <a:gs pos="100000">
+              <a:schemeClr val="phClr">
+                <a:shade val="20000"/>
+                <a:satMod val="255000"/>
+              </a:schemeClr>
+            </a:gs>
+          </a:gsLst>
+          <a:path path="circle">
+            <a:fillToRect l="50000" t="-80000" r="50000" b="180000"/>
+          </a:path>
+        </a:gradFill>
+        <a:gradFill rotWithShape="1">
+          <a:gsLst>
+            <a:gs pos="0">
+              <a:schemeClr val="phClr">
+                <a:tint val="80000"/>
+                <a:satMod val="300000"/>
+              </a:schemeClr>
+            </a:gs>
+            <a:gs pos="100000">
+              <a:schemeClr val="phClr">
+                <a:shade val="30000"/>
+                <a:satMod val="200000"/>
+              </a:schemeClr>
+            </a:gs>
+          </a:gsLst>
+          <a:path path="circle">
+            <a:fillToRect l="50000" t="50000" r="50000" b="50000"/>
+          </a:path>
+        </a:gradFill>
+      </a:bgFillStyleLst>
+    </a:fmtScheme>
+  </a:themeElements>
+  <a:objectDefaults>
+    <a:spDef>
+      <a:spPr/>
+      <a:bodyPr/>
+      <a:lstStyle/>
+      <a:style>
+        <a:lnRef idx="1">
+          <a:schemeClr val="accent1"/>
+        </a:lnRef>
+        <a:fillRef idx="3">
+          <a:schemeClr val="accent1"/>
+        </a:fillRef>
+        <a:effectRef idx="2">
+          <a:schemeClr val="accent1"/>
+        </a:effectRef>
+        <a:fontRef idx="minor">
+          <a:schemeClr val="lt1"/>
+        </a:fontRef>
+      </a:style>
+    </a:spDef>
+    <a:lnDef>
+      <a:spPr/>
+      <a:bodyPr/>
+      <a:lstStyle/>
+      <a:style>
+        <a:lnRef idx="2">
+          <a:schemeClr val="accent1"/>
+        </a:lnRef>
+        <a:fillRef idx="0">
+          <a:schemeClr val="accent1"/>
+        </a:fillRef>
+        <a:effectRef idx="1">
+          <a:schemeClr val="accent1"/>
+        </a:effectRef>
+        <a:fontRef idx="minor">
+          <a:schemeClr val="tx1"/>
+        </a:fontRef>
+      </a:style>
+    </a:lnDef>
+  </a:objectDefaults>
+  <a:extraClrSchemeLst/>
+</a:theme>
 </file>
</xml_diff>

<commit_message>
Check in remaining submission files; remove draft-capstone references
- Add walkthrough/progress/practice decks, ethics application, demo_reference
  (rehearsal kit), animations and their build scripts; refresh defense deck
- Fix draft-capstone references:
  * Capstone final project/README.md clone/cd steps -> real repo name
  * build_code_deck.py / build_progress_slides.py header comments
  * sanitize local "Draft-Captone Proposal Kellen" path out of captured test logs
- Exclude private supervisor voice note (.ogg) from version control

Co-Authored-By: Claude Opus 4.8 (1M context) <noreply@anthropic.com>
</commit_message>
<xml_diff>
--- a/Flood_Risk_Defense_Slides.pptx
+++ b/Flood_Risk_Defense_Slides.pptx
@@ -657,7 +657,7 @@
           <a:lstStyle/>
           <a:p>
             <a:r>
-              <a:t>Here is my most honest slide. My original target was 70% of predicted-high cells inside the official polygons. But that layer covers only 19% of my corridor, so 70% is mathematically impossible unless I make the label circular. I therefore reframed it to enrichment and an odds ratio. Predicted high-pressure is 1.59 times more concentrated in official zones than chance, and official cells are flagged high 1.84 times more often than others — and the model never saw those polygons in training. It rediscovers the official zone and extends it, which is the core contribution.</a:t>
+              <a:t>Here is my most honest slide. My original target was 70% of predicted-high cells inside the official polygons. But that layer covers only 19% of my corridor, so 70% is mathematically impossible unless I make the label circular. I therefore reframed it to enrichment and an odds ratio. Predicted high-pressure is 1.60 times more concentrated in official zones than chance, and official cells are flagged high 1.85 times more often than others — and the model never saw those polygons in training. It rediscovers the official zone and extends it, which is the core contribution.</a:t>
             </a:r>
           </a:p>
         </p:txBody>
@@ -937,7 +937,7 @@
           <a:lstStyle/>
           <a:p>
             <a:r>
-              <a:t>To conclude: all five objectives are met on real, open data with a strict temporal hold-out. The framework is accurate, interpretable, agrees with and extends the official flood map, and is fully reproducible. Thank you — I welcome your questions.</a:t>
+              <a:t>To conclude: all five objectives are met on real, open data with a temporal train, validation and test split. The framework is accurate, interpretable, agrees with and extends the official flood map, and is fully reproducible. Thank you — I welcome your questions.</a:t>
             </a:r>
           </a:p>
         </p:txBody>
@@ -1357,7 +1357,7 @@
           <a:lstStyle/>
           <a:p>
             <a:r>
-              <a:t>This is the question I most expect from you, so let me address it directly. My label is a flood-pressure score from rainfall and terrain. If I stopped there, the label would be a formula the model could simply reverse-engineer — and indeed an early version scored 0.99 F1, which is a warning sign, not a success. So I added an unobserved drainage-and-noise term the model cannot see, which drops performance to a realistic 0.83. Flood-pressure is a derived risk state, not a confirmed flood event.</a:t>
+              <a:t>This is the question I most expect from you, so let me address it directly. My label is a flood-pressure score from rainfall and terrain. If I stopped there, the label would be a formula the model could simply reverse-engineer — and indeed an early version scored 0.99 F1, which is a warning sign, not a success. So I added an unobserved drainage-and-noise term the model cannot see, which drops performance to a realistic 0.81. Flood-pressure is a derived risk state, not a confirmed flood event.</a:t>
             </a:r>
           </a:p>
         </p:txBody>
@@ -1427,7 +1427,7 @@
           <a:lstStyle/>
           <a:p>
             <a:r>
-              <a:t>I benchmark against two naive baselines so the machine learning has to earn its place, then interpretable models, then Random Forest and XGBoost with SHAP, and finally a Hidden Markov Model for the time dimension. Crucially I evaluate on a temporal hold-out: I train on 2018 to 2023 and test on the completely unseen year 2024 — so this is generalisation, not memorisation.</a:t>
+              <a:t>I benchmark against two naive baselines so the machine learning has to earn its place, then interpretable models, then Random Forest and XGBoost with SHAP, and finally a Hidden Markov Model for the time dimension. Crucially I use a temporal split with no shuffling: I fit on 2018 to 2022, hold out 2023 as a validation year to check for over-fitting, and test on the completely unseen year 2024. Macro-F1 is almost identical across train, validation and test — so this is genuine generalisation, not memorisation.</a:t>
             </a:r>
           </a:p>
         </p:txBody>
@@ -1497,7 +1497,7 @@
           <a:lstStyle/>
           <a:p>
             <a:r>
-              <a:t>On 2024, Random Forest is best with a macro-F1 of 0.831 and high-pressure recall of 0.867 — both above the 0.75 and 0.80 targets. XGBoost is close behind. Both baselines are clearly beaten — the rainfall-only baseline reaches just 0.62 — which proves the geospatial context adds real value. The confusion matrix shows strong Low and High detection; most error is on the transitional Moderate class, which is expected.</a:t>
+              <a:t>On 2024, XGBoost — my deployed model — is the best with a macro-F1 of 0.813 and high-pressure recall of 0.843, both above the 0.75 and 0.80 targets; Random Forest ties on F1 with slightly higher recall. Both baselines are clearly beaten — the rainfall-only baseline reaches just 0.63 — which proves the geospatial context adds real value. The confusion matrix shows strong Low and High detection; most error is on the transitional Moderate class, which is expected.</a:t>
             </a:r>
           </a:p>
         </p:txBody>
@@ -4768,6 +4768,21 @@
               <a:t>• Next-step accuracy 0.45 over 3 states (random = 0.33).</a:t>
             </a:r>
           </a:p>
+          <a:p>
+            <a:pPr>
+              <a:spcAft>
+                <a:spcPts val="600"/>
+              </a:spcAft>
+            </a:pPr>
+            <a:r>
+              <a:rPr sz="1800">
+                <a:solidFill>
+                  <a:srgbClr val="222222"/>
+                </a:solidFill>
+              </a:rPr>
+              <a:t>• Dashboard now shows a PER-CELL transition matrix: P(state tomorrow | today) for any selected cell — the Markov intuition, cell by cell.</a:t>
+            </a:r>
+          </a:p>
         </p:txBody>
       </p:sp>
       <p:pic>
@@ -4923,7 +4938,7 @@
                   <a:srgbClr val="444444"/>
                 </a:solidFill>
               </a:rPr>
-              <a:t>– Enrichment / lift: 1.59× over the 18.7% base rate.</a:t>
+              <a:t>– Enrichment / lift: 1.60× over the 18.7% base rate.</a:t>
             </a:r>
           </a:p>
           <a:p>
@@ -4938,7 +4953,7 @@
                   <a:srgbClr val="444444"/>
                 </a:solidFill>
               </a:rPr>
-              <a:t>– Inside-vs-outside High odds: 1.84× (30.7% vs 16.7%).</a:t>
+              <a:t>– Inside-vs-outside High odds: 1.85× (30.7% vs 16.7%).</a:t>
             </a:r>
           </a:p>
           <a:p>
@@ -5087,6 +5102,21 @@
                   <a:srgbClr val="222222"/>
                 </a:solidFill>
               </a:rPr>
+              <a:t>• Per-cell Markov transition matrix + train/validation/test performance panels.</a:t>
+            </a:r>
+          </a:p>
+          <a:p>
+            <a:pPr>
+              <a:spcAft>
+                <a:spcPts val="600"/>
+              </a:spcAft>
+            </a:pPr>
+            <a:r>
+              <a:rPr sz="1800">
+                <a:solidFill>
+                  <a:srgbClr val="222222"/>
+                </a:solidFill>
+              </a:rPr>
               <a:t>• Model &amp; HMM performance panels built in.</a:t>
             </a:r>
           </a:p>
@@ -5469,7 +5499,7 @@
                   <a:srgbClr val="222222"/>
                 </a:solidFill>
               </a:rPr>
-              <a:t>• All five objectives met on REAL, open data with a strict temporal hold-out.</a:t>
+              <a:t>• All five objectives met on REAL, open data with a temporal train/val/test split.</a:t>
             </a:r>
           </a:p>
           <a:p>
@@ -5484,7 +5514,7 @@
                   <a:srgbClr val="222222"/>
                 </a:solidFill>
               </a:rPr>
-              <a:t>• RF macro-F1 0.831, High-recall 0.867; baselines clearly beaten.</a:t>
+              <a:t>• XGBoost (deployed) macro-F1 0.813, High-recall 0.843; baselines clearly beaten.</a:t>
             </a:r>
           </a:p>
           <a:p>
@@ -5499,7 +5529,7 @@
                   <a:srgbClr val="222222"/>
                 </a:solidFill>
               </a:rPr>
-              <a:t>• Model independently reinforces (1.59×) and extends the official flood map.</a:t>
+              <a:t>• Model independently reinforces (1.60×) and extends the official flood map.</a:t>
             </a:r>
           </a:p>
           <a:p>
@@ -5603,7 +5633,7 @@
                   <a:srgbClr val="222222"/>
                 </a:solidFill>
               </a:rPr>
-              <a:t>• “Is your label circular?” → No — unobserved drainage latent + noise; F1 0.83 not 0.99.</a:t>
+              <a:t>• “Is your label circular?” → No — unobserved drainage latent + noise; F1 0.81 not 0.99.</a:t>
             </a:r>
           </a:p>
           <a:p>
@@ -5633,7 +5663,7 @@
                   <a:srgbClr val="222222"/>
                 </a:solidFill>
               </a:rPr>
-              <a:t>• “Why did spatial agreement miss 70%?” → Coarse 19% official layer; reframed to enrichment 1.59×.</a:t>
+              <a:t>• “Why did spatial agreement miss 70%?” → Coarse 19% official layer; reframed to enrichment 1.60×.</a:t>
             </a:r>
           </a:p>
           <a:p>
@@ -5956,7 +5986,7 @@
                   <a:srgbClr val="222222"/>
                 </a:solidFill>
               </a:rPr>
-              <a:t>• Train 2018–2023 · test on unseen 2024.</a:t>
+              <a:t>• Temporal split: train 2018–2022 · validation 2023 · test on unseen 2024.</a:t>
             </a:r>
           </a:p>
           <a:p>
@@ -6472,7 +6502,7 @@
                   <a:srgbClr val="444444"/>
                 </a:solidFill>
               </a:rPr>
-              <a:t>– With it, F1 ≈ 0.83 — realistic and honest.</a:t>
+              <a:t>– With it, F1 ≈ 0.81 — realistic and honest.</a:t>
             </a:r>
           </a:p>
           <a:p>
@@ -6636,7 +6666,22 @@
                   <a:srgbClr val="222222"/>
                 </a:solidFill>
               </a:rPr>
-              <a:t>• Strict temporal hold-out: train 2018–23, test on unseen 2024.</a:t>
+              <a:t>• Temporal split (no shuffle): train 2018–22, validate 2023, test on unseen 2024.</a:t>
+            </a:r>
+          </a:p>
+          <a:p>
+            <a:pPr>
+              <a:spcAft>
+                <a:spcPts val="600"/>
+              </a:spcAft>
+            </a:pPr>
+            <a:r>
+              <a:rPr sz="1800">
+                <a:solidFill>
+                  <a:srgbClr val="222222"/>
+                </a:solidFill>
+              </a:rPr>
+              <a:t>• Train ≈ validation ≈ test macro-F1 (no over-fitting; generalises across years).</a:t>
             </a:r>
           </a:p>
           <a:p>
@@ -6702,7 +6747,7 @@
                   <a:srgbClr val="123A5E"/>
                 </a:solidFill>
               </a:rPr>
-              <a:t>Results — 2024 hold-out</a:t>
+              <a:t>Results — 2024 test hold-out</a:t>
             </a:r>
           </a:p>
           <a:p>
@@ -6813,60 +6858,7 @@
                     <a:p>
                       <a:r>
                         <a:rPr sz="1400"/>
-                        <a:t>Random Forest</a:t>
-                      </a:r>
-                    </a:p>
-                  </a:txBody>
-                  <a:tcPr>
-                    <a:solidFill>
-                      <a:srgbClr val="E5F0E9"/>
-                    </a:solidFill>
-                  </a:tcPr>
-                </a:tc>
-                <a:tc>
-                  <a:txBody>
-                    <a:bodyPr/>
-                    <a:lstStyle/>
-                    <a:p>
-                      <a:r>
-                        <a:rPr sz="1400"/>
-                        <a:t>0.831</a:t>
-                      </a:r>
-                    </a:p>
-                  </a:txBody>
-                  <a:tcPr>
-                    <a:solidFill>
-                      <a:srgbClr val="E5F0E9"/>
-                    </a:solidFill>
-                  </a:tcPr>
-                </a:tc>
-                <a:tc>
-                  <a:txBody>
-                    <a:bodyPr/>
-                    <a:lstStyle/>
-                    <a:p>
-                      <a:r>
-                        <a:rPr sz="1400"/>
-                        <a:t>0.867</a:t>
-                      </a:r>
-                    </a:p>
-                  </a:txBody>
-                  <a:tcPr>
-                    <a:solidFill>
-                      <a:srgbClr val="E5F0E9"/>
-                    </a:solidFill>
-                  </a:tcPr>
-                </a:tc>
-              </a:tr>
-              <a:tr h="574765">
-                <a:tc>
-                  <a:txBody>
-                    <a:bodyPr/>
-                    <a:lstStyle/>
-                    <a:p>
-                      <a:r>
-                        <a:rPr sz="1400"/>
-                        <a:t>XGBoost</a:t>
+                        <a:t>XGBoost  (deployed, best)</a:t>
                       </a:r>
                     </a:p>
                   </a:txBody>
@@ -6900,7 +6892,60 @@
                     <a:p>
                       <a:r>
                         <a:rPr sz="1400"/>
-                        <a:t>0.847</a:t>
+                        <a:t>0.843</a:t>
+                      </a:r>
+                    </a:p>
+                  </a:txBody>
+                  <a:tcPr>
+                    <a:solidFill>
+                      <a:srgbClr val="E5F0E9"/>
+                    </a:solidFill>
+                  </a:tcPr>
+                </a:tc>
+              </a:tr>
+              <a:tr h="574765">
+                <a:tc>
+                  <a:txBody>
+                    <a:bodyPr/>
+                    <a:lstStyle/>
+                    <a:p>
+                      <a:r>
+                        <a:rPr sz="1400"/>
+                        <a:t>Random Forest</a:t>
+                      </a:r>
+                    </a:p>
+                  </a:txBody>
+                  <a:tcPr>
+                    <a:solidFill>
+                      <a:srgbClr val="E5F0E9"/>
+                    </a:solidFill>
+                  </a:tcPr>
+                </a:tc>
+                <a:tc>
+                  <a:txBody>
+                    <a:bodyPr/>
+                    <a:lstStyle/>
+                    <a:p>
+                      <a:r>
+                        <a:rPr sz="1400"/>
+                        <a:t>0.813</a:t>
+                      </a:r>
+                    </a:p>
+                  </a:txBody>
+                  <a:tcPr>
+                    <a:solidFill>
+                      <a:srgbClr val="E5F0E9"/>
+                    </a:solidFill>
+                  </a:tcPr>
+                </a:tc>
+                <a:tc>
+                  <a:txBody>
+                    <a:bodyPr/>
+                    <a:lstStyle/>
+                    <a:p>
+                      <a:r>
+                        <a:rPr sz="1400"/>
+                        <a:t>0.849</a:t>
                       </a:r>
                     </a:p>
                   </a:txBody>
@@ -6932,7 +6977,7 @@
                     <a:p>
                       <a:r>
                         <a:rPr sz="1400"/>
-                        <a:t>0.753</a:t>
+                        <a:t>0.750</a:t>
                       </a:r>
                     </a:p>
                   </a:txBody>
@@ -6945,7 +6990,7 @@
                     <a:p>
                       <a:r>
                         <a:rPr sz="1400"/>
-                        <a:t>0.793</a:t>
+                        <a:t>0.798</a:t>
                       </a:r>
                     </a:p>
                   </a:txBody>
@@ -6973,7 +7018,7 @@
                     <a:p>
                       <a:r>
                         <a:rPr sz="1400"/>
-                        <a:t>0.749</a:t>
+                        <a:t>0.750</a:t>
                       </a:r>
                     </a:p>
                   </a:txBody>
@@ -6986,7 +7031,7 @@
                     <a:p>
                       <a:r>
                         <a:rPr sz="1400"/>
-                        <a:t>0.821</a:t>
+                        <a:t>0.819</a:t>
                       </a:r>
                     </a:p>
                   </a:txBody>
@@ -7014,7 +7059,7 @@
                     <a:p>
                       <a:r>
                         <a:rPr sz="1400"/>
-                        <a:t>0.623</a:t>
+                        <a:t>0.626</a:t>
                       </a:r>
                     </a:p>
                   </a:txBody>
@@ -7081,7 +7126,7 @@
       </p:graphicFrame>
       <p:pic>
         <p:nvPicPr>
-          <p:cNvPr id="4" name="Picture 3" descr="confusion_RandomForest.png"/>
+          <p:cNvPr id="4" name="Picture 3" descr="confusion_XGBoost.png"/>
           <p:cNvPicPr>
             <a:picLocks noChangeAspect="1"/>
           </p:cNvPicPr>

</xml_diff>